<commit_message>
change .py to c++
</commit_message>
<xml_diff>
--- a/slides/Presentacion_RTI_EM.pptx
+++ b/slides/Presentacion_RTI_EM.pptx
@@ -2,24 +2,24 @@
 <file path=ppt/presentation.xml><?xml version="1.0" encoding="utf-8"?>
 <p:presentation xmlns:p="http://schemas.openxmlformats.org/presentationml/2006/main">
   <p:sldMasterIdLst>
-    <p:sldMasterId xmlns:r="http://schemas.openxmlformats.org/officeDocument/2006/relationships" id="2147483648" r:id="R955d0f5c76084e5d"/>
+    <p:sldMasterId xmlns:r="http://schemas.openxmlformats.org/officeDocument/2006/relationships" id="2147483648" r:id="R2d80adc0259441d9"/>
   </p:sldMasterIdLst>
   <p:notesMasterIdLst>
-    <p:notesMasterId xmlns:r="http://schemas.openxmlformats.org/officeDocument/2006/relationships" r:id="R53037746eaa44af7"/>
+    <p:notesMasterId xmlns:r="http://schemas.openxmlformats.org/officeDocument/2006/relationships" r:id="Rfc112cddabf34d60"/>
   </p:notesMasterIdLst>
   <p:sldIdLst>
-    <p:sldId xmlns:r="http://schemas.openxmlformats.org/officeDocument/2006/relationships" id="256" r:id="R3e3dd45928fd4819"/>
-    <p:sldId xmlns:r="http://schemas.openxmlformats.org/officeDocument/2006/relationships" id="257" r:id="R13e6829c0b0d4b1d"/>
-    <p:sldId xmlns:r="http://schemas.openxmlformats.org/officeDocument/2006/relationships" id="258" r:id="R8dc8a33a9e0d42e4"/>
-    <p:sldId xmlns:r="http://schemas.openxmlformats.org/officeDocument/2006/relationships" id="259" r:id="R5deb5908cb0142d1"/>
-    <p:sldId xmlns:r="http://schemas.openxmlformats.org/officeDocument/2006/relationships" id="260" r:id="Raabc95a233a9464e"/>
-    <p:sldId xmlns:r="http://schemas.openxmlformats.org/officeDocument/2006/relationships" id="261" r:id="Rea77d57de2c046b6"/>
-    <p:sldId xmlns:r="http://schemas.openxmlformats.org/officeDocument/2006/relationships" id="262" r:id="R7459f8bc7bfe45b1"/>
-    <p:sldId xmlns:r="http://schemas.openxmlformats.org/officeDocument/2006/relationships" id="263" r:id="Re0baba15857d4a87"/>
-    <p:sldId xmlns:r="http://schemas.openxmlformats.org/officeDocument/2006/relationships" id="264" r:id="Rc51c9563c3bb4001"/>
-    <p:sldId xmlns:r="http://schemas.openxmlformats.org/officeDocument/2006/relationships" id="265" r:id="Rd48b461bb7184753"/>
-    <p:sldId xmlns:r="http://schemas.openxmlformats.org/officeDocument/2006/relationships" id="266" r:id="R35980ba519444fbc"/>
-    <p:sldId xmlns:r="http://schemas.openxmlformats.org/officeDocument/2006/relationships" id="267" r:id="Rd07374114d254734"/>
+    <p:sldId xmlns:r="http://schemas.openxmlformats.org/officeDocument/2006/relationships" id="256" r:id="R17da7724c0744834"/>
+    <p:sldId xmlns:r="http://schemas.openxmlformats.org/officeDocument/2006/relationships" id="257" r:id="R3e1f991a8c114dc7"/>
+    <p:sldId xmlns:r="http://schemas.openxmlformats.org/officeDocument/2006/relationships" id="258" r:id="R5c986896027c40e9"/>
+    <p:sldId xmlns:r="http://schemas.openxmlformats.org/officeDocument/2006/relationships" id="259" r:id="R8dcb768871e240f2"/>
+    <p:sldId xmlns:r="http://schemas.openxmlformats.org/officeDocument/2006/relationships" id="260" r:id="R2604ce3e75d64f96"/>
+    <p:sldId xmlns:r="http://schemas.openxmlformats.org/officeDocument/2006/relationships" id="261" r:id="R43b3149314104447"/>
+    <p:sldId xmlns:r="http://schemas.openxmlformats.org/officeDocument/2006/relationships" id="262" r:id="R0c6f0ef92b8c4dbd"/>
+    <p:sldId xmlns:r="http://schemas.openxmlformats.org/officeDocument/2006/relationships" id="263" r:id="R9c49c9468bba428e"/>
+    <p:sldId xmlns:r="http://schemas.openxmlformats.org/officeDocument/2006/relationships" id="264" r:id="Ra57c6ad2f1de4c0f"/>
+    <p:sldId xmlns:r="http://schemas.openxmlformats.org/officeDocument/2006/relationships" id="265" r:id="R95c1d668986d496f"/>
+    <p:sldId xmlns:r="http://schemas.openxmlformats.org/officeDocument/2006/relationships" id="266" r:id="Ra8e8f3039ef64792"/>
+    <p:sldId xmlns:r="http://schemas.openxmlformats.org/officeDocument/2006/relationships" id="267" r:id="R12d93822abc344ea"/>
   </p:sldIdLst>
   <p:sldSz cx="12192000" cy="6858000"/>
   <p:notesSz cx="6858000" cy="9144000"/>
@@ -463,7 +463,7 @@
           </a:p>
           <a:p xmlns:a="http://schemas.openxmlformats.org/drawingml/2006/main">
             <a:r>
-              <a:t>Mi algoritmo asignado es Expectation-Maximization, o EM. Lo aplico a estimar ruido de señales RSS dentro de una simulación de Radio Tomographic Imaging, RTI. El objetivo es entender sus actualizaciones y comprobar qué recupera de datos cuyo modelo conocemos. Después evalúo una reconstrucción espacial. Todo proviene de observaciones sintéticas. La entrega incluye implementación en Python, resultados reproducibles y análisis de limitaciones.</a:t>
+              <a:t>Mi algoritmo asignado es Expectation-Maximization, o EM. Lo aplico a estimar ruido de señales RSS dentro de una simulación de Radio Tomographic Imaging, RTI. El objetivo es entender sus actualizaciones y comprobar qué recupera de datos cuyo modelo conocemos. Después evalúo una reconstrucción espacial. Todo proviene de observaciones sintéticas. La entrega incluye el algoritmo en C++17, resultados reproducibles y análisis de limitaciones.</a:t>
             </a:r>
           </a:p>
           <a:p xmlns:a="http://schemas.openxmlformats.org/drawingml/2006/main">
@@ -488,7 +488,7 @@
           </a:p>
           <a:p xmlns:a="http://schemas.openxmlformats.org/drawingml/2006/main">
             <a:r>
-              <a:t>Course prototype. Numerical data: results/python_preliminary. Instructor approved Python according to student confirmation.</a:t>
+              <a:t>Course prototype. EM implementation: em.cpp, C++17 with g++. Numerical data: results/python_preliminary, generated through the C++ EM backend. Python supplies synthetic inputs, RTI and plotting support.</a:t>
             </a:r>
           </a:p>
           <a:p xmlns:a="http://schemas.openxmlformats.org/drawingml/2006/main">
@@ -1438,7 +1438,7 @@
           </a:p>
           <a:p xmlns:a="http://schemas.openxmlformats.org/drawingml/2006/main">
             <a:r>
-              <a:t>Direct specialization of Dempster et al. [1] to fixed zero means. Code: em_ruido.py. Stopping and initialization cautions: Wu [2].</a:t>
+              <a:t>Direct specialization of Dempster et al. [1] to fixed zero means. C++ code: em.cpp. Stopping and initialization cautions: Wu [2].</a:t>
             </a:r>
           </a:p>
           <a:p xmlns:a="http://schemas.openxmlformats.org/drawingml/2006/main">
@@ -1683,7 +1683,7 @@
           </a:p>
           <a:p xmlns:a="http://schemas.openxmlformats.org/drawingml/2006/main">
             <a:r>
-              <a:t>El núcleo explicable está en em_ruido.py. Recibe residuos y valores iniciales, calcula densidades en logaritmos para evitar problemas numéricos, obtiene responsabilidades y actualiza momentos ponderados. Aplica un piso de sigma de 0,15 decibelios y devuelve si alcanzó la tolerancia. Con dos componentes fijas, cada iteración recorre N datos: cuesta orden N. Con I iteraciones, el coste total es orden I por N. Los vectores temporales ocupan orden N memoria. La cantidad de iteraciones depende de datos e inicialización. Detenerse por cambios pequeños no garantiza el óptimo global. Los costes de construir y resolver RTI son aparte de este núcleo.</a:t>
+              <a:t>El núcleo explicable está en em.cpp y se compila con g++ en C++17. Recibe residuos y valores iniciales, calcula densidades en logaritmos, obtiene responsabilidades y actualiza momentos ponderados. Aplica un piso de sigma de 0,15 decibelios y devuelve si alcanzó tolerancia. Con dos componentes fijas, cada iteración recorre N datos: cuesta orden N. Con I iteraciones, el coste total es orden I por N. El vector de responsabilidades ocupa orden N memoria. La cantidad de iteraciones depende de datos e inicialización. Python proporciona los datos y llama al ejecutable para los ajustes. Detenerse por cambios pequeños no garantiza el óptimo global. Los costes de RTI son aparte.</a:t>
             </a:r>
           </a:p>
           <a:p xmlns:a="http://schemas.openxmlformats.org/drawingml/2006/main">
@@ -1708,7 +1708,7 @@
           </a:p>
           <a:p xmlns:a="http://schemas.openxmlformats.org/drawingml/2006/main">
             <a:r>
-              <a:t>Code: em_ruido.py. N: number of residuals. I: number of iterations. Two fixed components. Counts exclude RTI, plotting and I/O. Convergence caution: Wu [2].</a:t>
+              <a:t>Code: em.cpp, C++17 compiled with g++ -std=c++17 -O2. Run build/em.exe --demo for the hand-computed example. N: number of residuals, I: number of iterations, two fixed components. Counts exclude RTI, plotting and I/O. Python adapter em_cpp.py calls the executable for all experimental EM fits. Convergence caution: Wu [2].</a:t>
             </a:r>
           </a:p>
           <a:p xmlns:a="http://schemas.openxmlformats.org/drawingml/2006/main">
@@ -2055,7 +2055,7 @@
           <p:cNvPr id="3" name="Title">
             <a:extLst xmlns:a="http://schemas.openxmlformats.org/drawingml/2006/main">
               <a:ext uri="{FF2B5EF4-FFF2-40B4-BE49-F238E27FC236}">
-                <a16:creationId xmlns:a16="http://schemas.microsoft.com/office/drawing/2014/main" id="{DE3A135C-6D79-4155-8441-13C24B14A36A}"/>
+                <a16:creationId xmlns:a16="http://schemas.microsoft.com/office/drawing/2014/main" id="{FA80DD65-4C09-4F0C-8A1C-FBCA4672EE8A}"/>
               </a:ext>
             </a:extLst>
           </p:cNvPr>
@@ -2284,7 +2284,7 @@
           <p:cNvPr id="2" name="Subtitle">
             <a:extLst xmlns:a="http://schemas.openxmlformats.org/drawingml/2006/main">
               <a:ext uri="{FF2B5EF4-FFF2-40B4-BE49-F238E27FC236}">
-                <a16:creationId xmlns:a16="http://schemas.microsoft.com/office/drawing/2014/main" id="{66D4D875-AAB9-4C62-9E83-7D416BB0E0A3}"/>
+                <a16:creationId xmlns:a16="http://schemas.microsoft.com/office/drawing/2014/main" id="{6E336D83-5148-4E34-8C01-664B8FDF2553}"/>
               </a:ext>
             </a:extLst>
           </p:cNvPr>
@@ -2530,7 +2530,7 @@
           <p:cNvPr id="2" name="Section title">
             <a:extLst xmlns:a="http://schemas.openxmlformats.org/drawingml/2006/main">
               <a:ext uri="{FF2B5EF4-FFF2-40B4-BE49-F238E27FC236}">
-                <a16:creationId xmlns:a16="http://schemas.microsoft.com/office/drawing/2014/main" id="{839420DF-E3BE-454B-816B-6C5BFD464AC5}"/>
+                <a16:creationId xmlns:a16="http://schemas.microsoft.com/office/drawing/2014/main" id="{9333C8FC-8036-4715-A1F0-119851E1B6F9}"/>
               </a:ext>
             </a:extLst>
           </p:cNvPr>
@@ -2776,7 +2776,7 @@
           <p:cNvPr id="3" name="Title">
             <a:extLst xmlns:a="http://schemas.openxmlformats.org/drawingml/2006/main">
               <a:ext uri="{FF2B5EF4-FFF2-40B4-BE49-F238E27FC236}">
-                <a16:creationId xmlns:a16="http://schemas.microsoft.com/office/drawing/2014/main" id="{ECE0FED3-6A9A-4BB7-9DF1-E24F40835F92}"/>
+                <a16:creationId xmlns:a16="http://schemas.microsoft.com/office/drawing/2014/main" id="{C4D188AA-001C-497E-8D24-2E3F1A904D28}"/>
               </a:ext>
             </a:extLst>
           </p:cNvPr>
@@ -3005,7 +3005,7 @@
           <p:cNvPr id="2" name="Body">
             <a:extLst xmlns:a="http://schemas.openxmlformats.org/drawingml/2006/main">
               <a:ext uri="{FF2B5EF4-FFF2-40B4-BE49-F238E27FC236}">
-                <a16:creationId xmlns:a16="http://schemas.microsoft.com/office/drawing/2014/main" id="{55C0DD64-0073-400C-A6F1-E1EF273CAF38}"/>
+                <a16:creationId xmlns:a16="http://schemas.microsoft.com/office/drawing/2014/main" id="{39069956-40EE-4013-AE61-070BE061C26C}"/>
               </a:ext>
             </a:extLst>
           </p:cNvPr>
@@ -3251,7 +3251,7 @@
           <p:cNvPr id="4" name="Title">
             <a:extLst xmlns:a="http://schemas.openxmlformats.org/drawingml/2006/main">
               <a:ext uri="{FF2B5EF4-FFF2-40B4-BE49-F238E27FC236}">
-                <a16:creationId xmlns:a16="http://schemas.microsoft.com/office/drawing/2014/main" id="{B517C848-4D51-4E70-B086-7DC517F0D824}"/>
+                <a16:creationId xmlns:a16="http://schemas.microsoft.com/office/drawing/2014/main" id="{5D3DD953-8641-45AF-9805-5D3127191817}"/>
               </a:ext>
             </a:extLst>
           </p:cNvPr>
@@ -3480,7 +3480,7 @@
           <p:cNvPr id="2" name="Left column">
             <a:extLst xmlns:a="http://schemas.openxmlformats.org/drawingml/2006/main">
               <a:ext uri="{FF2B5EF4-FFF2-40B4-BE49-F238E27FC236}">
-                <a16:creationId xmlns:a16="http://schemas.microsoft.com/office/drawing/2014/main" id="{F627EEC7-557B-4FA3-9010-FCD5A3346A25}"/>
+                <a16:creationId xmlns:a16="http://schemas.microsoft.com/office/drawing/2014/main" id="{D31F3754-B2DD-4B05-9C25-FBB958331DEA}"/>
               </a:ext>
             </a:extLst>
           </p:cNvPr>
@@ -3709,7 +3709,7 @@
           <p:cNvPr id="3" name="Right column">
             <a:extLst xmlns:a="http://schemas.openxmlformats.org/drawingml/2006/main">
               <a:ext uri="{FF2B5EF4-FFF2-40B4-BE49-F238E27FC236}">
-                <a16:creationId xmlns:a16="http://schemas.microsoft.com/office/drawing/2014/main" id="{06CC4476-B3A2-4BE2-8D21-35778E168B41}"/>
+                <a16:creationId xmlns:a16="http://schemas.microsoft.com/office/drawing/2014/main" id="{7F316017-4418-4C8C-8C33-8F0CF34DC37E}"/>
               </a:ext>
             </a:extLst>
           </p:cNvPr>
@@ -3955,7 +3955,7 @@
           <p:cNvPr id="3" name="Title">
             <a:extLst xmlns:a="http://schemas.openxmlformats.org/drawingml/2006/main">
               <a:ext uri="{FF2B5EF4-FFF2-40B4-BE49-F238E27FC236}">
-                <a16:creationId xmlns:a16="http://schemas.microsoft.com/office/drawing/2014/main" id="{4B3F75DC-AE49-46B2-92B2-838AF5EEEC6C}"/>
+                <a16:creationId xmlns:a16="http://schemas.microsoft.com/office/drawing/2014/main" id="{73A1E156-8285-46A4-939B-D6A860932BAE}"/>
               </a:ext>
             </a:extLst>
           </p:cNvPr>
@@ -4184,7 +4184,7 @@
           <p:cNvPr id="2" name="Left column">
             <a:extLst xmlns:a="http://schemas.openxmlformats.org/drawingml/2006/main">
               <a:ext uri="{FF2B5EF4-FFF2-40B4-BE49-F238E27FC236}">
-                <a16:creationId xmlns:a16="http://schemas.microsoft.com/office/drawing/2014/main" id="{5B20B763-6D5B-45B0-9FC6-6D4EBD1F73A3}"/>
+                <a16:creationId xmlns:a16="http://schemas.microsoft.com/office/drawing/2014/main" id="{37E5AB6E-F4B6-45C0-8A01-03D47791A009}"/>
               </a:ext>
             </a:extLst>
           </p:cNvPr>
@@ -4451,12 +4451,12 @@
   </p:cSld>
   <p:clrMap bg1="lt1" tx1="dk1" bg2="lt2" tx2="dk2" accent1="accent1" accent2="accent2" accent3="accent3" accent4="accent4" accent5="accent5" accent6="accent6" hlink="hlink" folHlink="folHlink"/>
   <p:sldLayoutIdLst>
-    <p:sldLayoutId xmlns:r="http://schemas.openxmlformats.org/officeDocument/2006/relationships" id="2147483649" r:id="Rb3f4145e509143df"/>
-    <p:sldLayoutId xmlns:r="http://schemas.openxmlformats.org/officeDocument/2006/relationships" id="2147483650" r:id="Rf299ad5c35734bdd"/>
-    <p:sldLayoutId xmlns:r="http://schemas.openxmlformats.org/officeDocument/2006/relationships" id="2147483651" r:id="Re5721519d4234e3c"/>
-    <p:sldLayoutId xmlns:r="http://schemas.openxmlformats.org/officeDocument/2006/relationships" id="2147483652" r:id="R346934ffdde94691"/>
-    <p:sldLayoutId xmlns:r="http://schemas.openxmlformats.org/officeDocument/2006/relationships" id="2147483653" r:id="R628275ffe90049ff"/>
-    <p:sldLayoutId xmlns:r="http://schemas.openxmlformats.org/officeDocument/2006/relationships" id="2147483654" r:id="Rfccca3ef0fff4af0"/>
+    <p:sldLayoutId xmlns:r="http://schemas.openxmlformats.org/officeDocument/2006/relationships" id="2147483649" r:id="Ra21b71cfe74d4b9e"/>
+    <p:sldLayoutId xmlns:r="http://schemas.openxmlformats.org/officeDocument/2006/relationships" id="2147483650" r:id="R66811559ed964530"/>
+    <p:sldLayoutId xmlns:r="http://schemas.openxmlformats.org/officeDocument/2006/relationships" id="2147483651" r:id="R1d212685da334fb3"/>
+    <p:sldLayoutId xmlns:r="http://schemas.openxmlformats.org/officeDocument/2006/relationships" id="2147483652" r:id="Rfab20587601b4ffc"/>
+    <p:sldLayoutId xmlns:r="http://schemas.openxmlformats.org/officeDocument/2006/relationships" id="2147483653" r:id="R5427fd4e1b004012"/>
+    <p:sldLayoutId xmlns:r="http://schemas.openxmlformats.org/officeDocument/2006/relationships" id="2147483654" r:id="R3659746a973745be"/>
   </p:sldLayoutIdLst>
   <p:txStyles>
     <p:titleStyle>
@@ -5007,7 +5007,7 @@
           <p:cNvPr id="8" name="">
             <a:extLst xmlns:a="http://schemas.openxmlformats.org/drawingml/2006/main">
               <a:ext uri="{FF2B5EF4-FFF2-40B4-BE49-F238E27FC236}">
-                <a16:creationId xmlns:a16="http://schemas.microsoft.com/office/drawing/2014/main" id="{3CFFC131-10B2-413F-974E-C53836881826}"/>
+                <a16:creationId xmlns:a16="http://schemas.microsoft.com/office/drawing/2014/main" id="{78028326-A7F3-4822-BFB9-CF2789F6C037}"/>
               </a:ext>
             </a:extLst>
           </p:cNvPr>
@@ -5165,7 +5165,7 @@
           <p:cNvPr id="2" name="">
             <a:extLst xmlns:a="http://schemas.openxmlformats.org/drawingml/2006/main">
               <a:ext uri="{FF2B5EF4-FFF2-40B4-BE49-F238E27FC236}">
-                <a16:creationId xmlns:a16="http://schemas.microsoft.com/office/drawing/2014/main" id="{72C6E956-47C3-4DAC-A465-EB5D76A7D7B6}"/>
+                <a16:creationId xmlns:a16="http://schemas.microsoft.com/office/drawing/2014/main" id="{9933CE11-D5EC-46DA-816D-09DAD353502B}"/>
               </a:ext>
             </a:extLst>
           </p:cNvPr>
@@ -5323,7 +5323,7 @@
           <p:cNvPr id="3" name="">
             <a:extLst xmlns:a="http://schemas.openxmlformats.org/drawingml/2006/main">
               <a:ext uri="{FF2B5EF4-FFF2-40B4-BE49-F238E27FC236}">
-                <a16:creationId xmlns:a16="http://schemas.microsoft.com/office/drawing/2014/main" id="{0C3B4374-A0E9-4F9E-A6C4-26C5FD1EA504}"/>
+                <a16:creationId xmlns:a16="http://schemas.microsoft.com/office/drawing/2014/main" id="{2346FA4A-FE3E-4BA9-9CA0-7548BE0F6000}"/>
               </a:ext>
             </a:extLst>
           </p:cNvPr>
@@ -5481,7 +5481,7 @@
           <p:cNvPr id="4" name="">
             <a:extLst xmlns:a="http://schemas.openxmlformats.org/drawingml/2006/main">
               <a:ext uri="{FF2B5EF4-FFF2-40B4-BE49-F238E27FC236}">
-                <a16:creationId xmlns:a16="http://schemas.microsoft.com/office/drawing/2014/main" id="{9E7037A9-B664-49A1-946D-D6298E740D15}"/>
+                <a16:creationId xmlns:a16="http://schemas.microsoft.com/office/drawing/2014/main" id="{42FE90FB-8B99-4EF3-90D2-0CB28D816DDB}"/>
               </a:ext>
             </a:extLst>
           </p:cNvPr>
@@ -5639,7 +5639,7 @@
           <p:cNvPr id="5" name="">
             <a:extLst xmlns:a="http://schemas.openxmlformats.org/drawingml/2006/main">
               <a:ext uri="{FF2B5EF4-FFF2-40B4-BE49-F238E27FC236}">
-                <a16:creationId xmlns:a16="http://schemas.microsoft.com/office/drawing/2014/main" id="{5138301F-8FF6-4269-BDBD-9870900FBC2C}"/>
+                <a16:creationId xmlns:a16="http://schemas.microsoft.com/office/drawing/2014/main" id="{AF2D4128-F5A5-4213-9967-EA1F82B12A78}"/>
               </a:ext>
             </a:extLst>
           </p:cNvPr>
@@ -5843,7 +5843,7 @@
           <p:cNvPr id="6" name="">
             <a:extLst xmlns:a="http://schemas.openxmlformats.org/drawingml/2006/main">
               <a:ext uri="{FF2B5EF4-FFF2-40B4-BE49-F238E27FC236}">
-                <a16:creationId xmlns:a16="http://schemas.microsoft.com/office/drawing/2014/main" id="{CDCA9E77-A728-4F40-B030-4942E1CB77A4}"/>
+                <a16:creationId xmlns:a16="http://schemas.microsoft.com/office/drawing/2014/main" id="{F37F3C31-01A3-447D-93DC-E6139955135F}"/>
               </a:ext>
             </a:extLst>
           </p:cNvPr>
@@ -5991,7 +5991,7 @@
                 <a:ea typeface="Arial"/>
                 <a:cs typeface="Arial"/>
               </a:rPr>
-              <a:t>Implementation and preliminary results</a:t>
+              <a:t>C++17 implementation and preliminary results</a:t>
             </a:r>
           </a:p>
         </p:txBody>
@@ -6001,7 +6001,7 @@
           <p:cNvPr id="7" name="">
             <a:extLst xmlns:a="http://schemas.openxmlformats.org/drawingml/2006/main">
               <a:ext uri="{FF2B5EF4-FFF2-40B4-BE49-F238E27FC236}">
-                <a16:creationId xmlns:a16="http://schemas.microsoft.com/office/drawing/2014/main" id="{9706161E-20C0-4987-8DC2-2716798DC3F6}"/>
+                <a16:creationId xmlns:a16="http://schemas.microsoft.com/office/drawing/2014/main" id="{341220BC-A152-436C-88F4-6A9ECBBA8A5E}"/>
               </a:ext>
             </a:extLst>
           </p:cNvPr>
@@ -6157,7 +6157,7 @@
     </p:spTree>
     <p:extLst>
       <p:ext uri="{BB962C8B-B14F-4D97-AF65-F5344CB8AC3E}">
-        <p14:creationId xmlns:p14="http://schemas.microsoft.com/office/powerpoint/2010/main" val="1460221624"/>
+        <p14:creationId xmlns:p14="http://schemas.microsoft.com/office/powerpoint/2010/main" val="889966089"/>
       </p:ext>
     </p:extLst>
   </p:cSld>
@@ -6188,7 +6188,7 @@
           <p:cNvPr id="7" name="">
             <a:extLst xmlns:a="http://schemas.openxmlformats.org/drawingml/2006/main">
               <a:ext uri="{FF2B5EF4-FFF2-40B4-BE49-F238E27FC236}">
-                <a16:creationId xmlns:a16="http://schemas.microsoft.com/office/drawing/2014/main" id="{AEEE86E0-AFED-4573-A162-77DE76BAD406}"/>
+                <a16:creationId xmlns:a16="http://schemas.microsoft.com/office/drawing/2014/main" id="{BD5DF460-AFEF-4721-B284-03C136731574}"/>
               </a:ext>
             </a:extLst>
           </p:cNvPr>
@@ -6346,7 +6346,7 @@
           <p:cNvPr id="2" name="">
             <a:extLst xmlns:a="http://schemas.openxmlformats.org/drawingml/2006/main">
               <a:ext uri="{FF2B5EF4-FFF2-40B4-BE49-F238E27FC236}">
-                <a16:creationId xmlns:a16="http://schemas.microsoft.com/office/drawing/2014/main" id="{BEDB0B8F-DFF7-4BB7-A1E1-43E7111A3CE4}"/>
+                <a16:creationId xmlns:a16="http://schemas.microsoft.com/office/drawing/2014/main" id="{96B65B11-C197-48A0-9944-BE2D7C3E310D}"/>
               </a:ext>
             </a:extLst>
           </p:cNvPr>
@@ -6504,7 +6504,7 @@
           <p:cNvPr id="3" name="">
             <a:extLst xmlns:a="http://schemas.openxmlformats.org/drawingml/2006/main">
               <a:ext uri="{FF2B5EF4-FFF2-40B4-BE49-F238E27FC236}">
-                <a16:creationId xmlns:a16="http://schemas.microsoft.com/office/drawing/2014/main" id="{43F700F7-B0AF-4CEC-ADDF-6A397F09429D}"/>
+                <a16:creationId xmlns:a16="http://schemas.microsoft.com/office/drawing/2014/main" id="{D025E4A3-A51E-4EB6-9B73-B8CF2754A460}"/>
               </a:ext>
             </a:extLst>
           </p:cNvPr>
@@ -6662,7 +6662,7 @@
           <p:cNvPr id="4" name="">
             <a:extLst xmlns:a="http://schemas.openxmlformats.org/drawingml/2006/main">
               <a:ext uri="{FF2B5EF4-FFF2-40B4-BE49-F238E27FC236}">
-                <a16:creationId xmlns:a16="http://schemas.microsoft.com/office/drawing/2014/main" id="{58EACD7A-C262-430E-86FC-71EBFE28EA70}"/>
+                <a16:creationId xmlns:a16="http://schemas.microsoft.com/office/drawing/2014/main" id="{81746DA4-6462-4779-8230-84EBAE4B6CCC}"/>
               </a:ext>
             </a:extLst>
           </p:cNvPr>
@@ -7289,7 +7289,7 @@
           <p:cNvPr id="5" name="">
             <a:extLst xmlns:a="http://schemas.openxmlformats.org/drawingml/2006/main">
               <a:ext uri="{FF2B5EF4-FFF2-40B4-BE49-F238E27FC236}">
-                <a16:creationId xmlns:a16="http://schemas.microsoft.com/office/drawing/2014/main" id="{7908DC4B-7B61-4416-9107-FAEA1DD82241}"/>
+                <a16:creationId xmlns:a16="http://schemas.microsoft.com/office/drawing/2014/main" id="{62B93C28-AE41-4D73-8BDC-F9C5EE336EB3}"/>
               </a:ext>
             </a:extLst>
           </p:cNvPr>
@@ -7470,7 +7470,7 @@
           <p:cNvPr id="6" name="">
             <a:extLst xmlns:a="http://schemas.openxmlformats.org/drawingml/2006/main">
               <a:ext uri="{FF2B5EF4-FFF2-40B4-BE49-F238E27FC236}">
-                <a16:creationId xmlns:a16="http://schemas.microsoft.com/office/drawing/2014/main" id="{7C45D4F1-4C56-4139-A336-68F11A31D529}"/>
+                <a16:creationId xmlns:a16="http://schemas.microsoft.com/office/drawing/2014/main" id="{ED255DF4-2C91-4AAB-A343-3B0F80683800}"/>
               </a:ext>
             </a:extLst>
           </p:cNvPr>
@@ -7626,7 +7626,7 @@
     </p:spTree>
     <p:extLst>
       <p:ext uri="{BB962C8B-B14F-4D97-AF65-F5344CB8AC3E}">
-        <p14:creationId xmlns:p14="http://schemas.microsoft.com/office/powerpoint/2010/main" val="1970683363"/>
+        <p14:creationId xmlns:p14="http://schemas.microsoft.com/office/powerpoint/2010/main" val="170386404"/>
       </p:ext>
     </p:extLst>
   </p:cSld>
@@ -7657,7 +7657,7 @@
           <p:cNvPr id="9" name="">
             <a:extLst xmlns:a="http://schemas.openxmlformats.org/drawingml/2006/main">
               <a:ext uri="{FF2B5EF4-FFF2-40B4-BE49-F238E27FC236}">
-                <a16:creationId xmlns:a16="http://schemas.microsoft.com/office/drawing/2014/main" id="{08555712-84DA-4C92-BE5A-E1A68C340600}"/>
+                <a16:creationId xmlns:a16="http://schemas.microsoft.com/office/drawing/2014/main" id="{2FB6B01C-F006-49E5-A569-B611A62F5242}"/>
               </a:ext>
             </a:extLst>
           </p:cNvPr>
@@ -7815,7 +7815,7 @@
           <p:cNvPr id="2" name="">
             <a:extLst xmlns:a="http://schemas.openxmlformats.org/drawingml/2006/main">
               <a:ext uri="{FF2B5EF4-FFF2-40B4-BE49-F238E27FC236}">
-                <a16:creationId xmlns:a16="http://schemas.microsoft.com/office/drawing/2014/main" id="{7F724C13-939D-4BF8-ACDE-9A32F4D5501A}"/>
+                <a16:creationId xmlns:a16="http://schemas.microsoft.com/office/drawing/2014/main" id="{735F178D-2F4F-48FC-ABDE-515FA57AFCC3}"/>
               </a:ext>
             </a:extLst>
           </p:cNvPr>
@@ -7973,7 +7973,7 @@
           <p:cNvPr id="3" name="">
             <a:extLst xmlns:a="http://schemas.openxmlformats.org/drawingml/2006/main">
               <a:ext uri="{FF2B5EF4-FFF2-40B4-BE49-F238E27FC236}">
-                <a16:creationId xmlns:a16="http://schemas.microsoft.com/office/drawing/2014/main" id="{E699DCE8-7367-4BEB-A303-AD893B67C119}"/>
+                <a16:creationId xmlns:a16="http://schemas.microsoft.com/office/drawing/2014/main" id="{17D63472-6CAE-4971-A32B-A0EBC9DABEF9}"/>
               </a:ext>
             </a:extLst>
           </p:cNvPr>
@@ -8131,7 +8131,7 @@
           <p:cNvPr id="4" name="">
             <a:extLst xmlns:a="http://schemas.openxmlformats.org/drawingml/2006/main">
               <a:ext uri="{FF2B5EF4-FFF2-40B4-BE49-F238E27FC236}">
-                <a16:creationId xmlns:a16="http://schemas.microsoft.com/office/drawing/2014/main" id="{FE3E4DCF-4F7F-4789-93F5-BDC3D4658C1D}"/>
+                <a16:creationId xmlns:a16="http://schemas.microsoft.com/office/drawing/2014/main" id="{F170CCD6-B369-416F-9438-F927463516D6}"/>
               </a:ext>
             </a:extLst>
           </p:cNvPr>
@@ -8289,7 +8289,7 @@
           <p:cNvPr id="5" name="">
             <a:extLst xmlns:a="http://schemas.openxmlformats.org/drawingml/2006/main">
               <a:ext uri="{FF2B5EF4-FFF2-40B4-BE49-F238E27FC236}">
-                <a16:creationId xmlns:a16="http://schemas.microsoft.com/office/drawing/2014/main" id="{1F66BD69-476B-47C9-895A-15DA7BA62A77}"/>
+                <a16:creationId xmlns:a16="http://schemas.microsoft.com/office/drawing/2014/main" id="{21C471B6-6B74-4452-949A-45E2E5853E73}"/>
               </a:ext>
             </a:extLst>
           </p:cNvPr>
@@ -8493,7 +8493,7 @@
           <p:cNvPr id="6" name="">
             <a:extLst xmlns:a="http://schemas.openxmlformats.org/drawingml/2006/main">
               <a:ext uri="{FF2B5EF4-FFF2-40B4-BE49-F238E27FC236}">
-                <a16:creationId xmlns:a16="http://schemas.microsoft.com/office/drawing/2014/main" id="{3D252087-3FB0-4535-A3F4-34932029A72B}"/>
+                <a16:creationId xmlns:a16="http://schemas.microsoft.com/office/drawing/2014/main" id="{4E94CE21-15A8-4934-BA3B-760A250C1551}"/>
               </a:ext>
             </a:extLst>
           </p:cNvPr>
@@ -8651,7 +8651,7 @@
           <p:cNvPr id="7" name="">
             <a:extLst xmlns:a="http://schemas.openxmlformats.org/drawingml/2006/main">
               <a:ext uri="{FF2B5EF4-FFF2-40B4-BE49-F238E27FC236}">
-                <a16:creationId xmlns:a16="http://schemas.microsoft.com/office/drawing/2014/main" id="{F49EBDA6-52C6-45E3-9DB4-9FD7C80A0B19}"/>
+                <a16:creationId xmlns:a16="http://schemas.microsoft.com/office/drawing/2014/main" id="{5CE3D2B8-78E2-4173-8395-81B235F77ED0}"/>
               </a:ext>
             </a:extLst>
           </p:cNvPr>
@@ -8832,7 +8832,7 @@
           <p:cNvPr id="8" name="">
             <a:extLst xmlns:a="http://schemas.openxmlformats.org/drawingml/2006/main">
               <a:ext uri="{FF2B5EF4-FFF2-40B4-BE49-F238E27FC236}">
-                <a16:creationId xmlns:a16="http://schemas.microsoft.com/office/drawing/2014/main" id="{BDC2A709-164A-4511-969A-4132CD00C6AC}"/>
+                <a16:creationId xmlns:a16="http://schemas.microsoft.com/office/drawing/2014/main" id="{82C11206-F540-45C6-B14E-51921C8D45BB}"/>
               </a:ext>
             </a:extLst>
           </p:cNvPr>
@@ -8988,7 +8988,7 @@
     </p:spTree>
     <p:extLst>
       <p:ext uri="{BB962C8B-B14F-4D97-AF65-F5344CB8AC3E}">
-        <p14:creationId xmlns:p14="http://schemas.microsoft.com/office/powerpoint/2010/main" val="139138888"/>
+        <p14:creationId xmlns:p14="http://schemas.microsoft.com/office/powerpoint/2010/main" val="433789994"/>
       </p:ext>
     </p:extLst>
   </p:cSld>
@@ -9019,7 +9019,7 @@
           <p:cNvPr id="8" name="">
             <a:extLst xmlns:a="http://schemas.openxmlformats.org/drawingml/2006/main">
               <a:ext uri="{FF2B5EF4-FFF2-40B4-BE49-F238E27FC236}">
-                <a16:creationId xmlns:a16="http://schemas.microsoft.com/office/drawing/2014/main" id="{B066A901-9A49-4F23-8D3D-3F81B6CB995B}"/>
+                <a16:creationId xmlns:a16="http://schemas.microsoft.com/office/drawing/2014/main" id="{FC11B141-3E30-4151-B9E7-35B7A1F0B1E3}"/>
               </a:ext>
             </a:extLst>
           </p:cNvPr>
@@ -9177,7 +9177,7 @@
           <p:cNvPr id="2" name="">
             <a:extLst xmlns:a="http://schemas.openxmlformats.org/drawingml/2006/main">
               <a:ext uri="{FF2B5EF4-FFF2-40B4-BE49-F238E27FC236}">
-                <a16:creationId xmlns:a16="http://schemas.microsoft.com/office/drawing/2014/main" id="{D0522BCA-4B97-40A7-A844-C21541AE5477}"/>
+                <a16:creationId xmlns:a16="http://schemas.microsoft.com/office/drawing/2014/main" id="{FA192E4C-F2AC-454A-9039-451A3C5AE7F1}"/>
               </a:ext>
             </a:extLst>
           </p:cNvPr>
@@ -9335,7 +9335,7 @@
           <p:cNvPr id="3" name="">
             <a:extLst xmlns:a="http://schemas.openxmlformats.org/drawingml/2006/main">
               <a:ext uri="{FF2B5EF4-FFF2-40B4-BE49-F238E27FC236}">
-                <a16:creationId xmlns:a16="http://schemas.microsoft.com/office/drawing/2014/main" id="{7283D857-D132-4246-8316-FEF04122136C}"/>
+                <a16:creationId xmlns:a16="http://schemas.microsoft.com/office/drawing/2014/main" id="{069F87D4-A95F-4B79-BBAF-6A9E566F4F70}"/>
               </a:ext>
             </a:extLst>
           </p:cNvPr>
@@ -9493,7 +9493,7 @@
           <p:cNvPr id="4" name="">
             <a:extLst xmlns:a="http://schemas.openxmlformats.org/drawingml/2006/main">
               <a:ext uri="{FF2B5EF4-FFF2-40B4-BE49-F238E27FC236}">
-                <a16:creationId xmlns:a16="http://schemas.microsoft.com/office/drawing/2014/main" id="{B49CA91A-044C-4302-8139-7592256DE787}"/>
+                <a16:creationId xmlns:a16="http://schemas.microsoft.com/office/drawing/2014/main" id="{FE7C3022-6C80-476F-8B67-56F2D28FC0B6}"/>
               </a:ext>
             </a:extLst>
           </p:cNvPr>
@@ -9674,7 +9674,7 @@
           <p:cNvPr id="5" name="">
             <a:extLst xmlns:a="http://schemas.openxmlformats.org/drawingml/2006/main">
               <a:ext uri="{FF2B5EF4-FFF2-40B4-BE49-F238E27FC236}">
-                <a16:creationId xmlns:a16="http://schemas.microsoft.com/office/drawing/2014/main" id="{5CD9972F-B40C-4D6B-8C25-A11650F3FA9B}"/>
+                <a16:creationId xmlns:a16="http://schemas.microsoft.com/office/drawing/2014/main" id="{621CD17E-FAF4-424A-8855-5BC9E1AD2710}"/>
               </a:ext>
             </a:extLst>
           </p:cNvPr>
@@ -9855,7 +9855,7 @@
           <p:cNvPr id="6" name="">
             <a:extLst xmlns:a="http://schemas.openxmlformats.org/drawingml/2006/main">
               <a:ext uri="{FF2B5EF4-FFF2-40B4-BE49-F238E27FC236}">
-                <a16:creationId xmlns:a16="http://schemas.microsoft.com/office/drawing/2014/main" id="{336604BF-C8DA-464C-BF1D-2E8C39BECC1E}"/>
+                <a16:creationId xmlns:a16="http://schemas.microsoft.com/office/drawing/2014/main" id="{B1D31E9B-52B7-44C9-A82E-B8E2A4DDC3A6}"/>
               </a:ext>
             </a:extLst>
           </p:cNvPr>
@@ -10036,7 +10036,7 @@
           <p:cNvPr id="7" name="">
             <a:extLst xmlns:a="http://schemas.openxmlformats.org/drawingml/2006/main">
               <a:ext uri="{FF2B5EF4-FFF2-40B4-BE49-F238E27FC236}">
-                <a16:creationId xmlns:a16="http://schemas.microsoft.com/office/drawing/2014/main" id="{EBCA6E1A-8B8E-446E-B6C4-82DB6A4055E6}"/>
+                <a16:creationId xmlns:a16="http://schemas.microsoft.com/office/drawing/2014/main" id="{91C01C3A-6F3B-41AD-A41B-D12AA14DFF75}"/>
               </a:ext>
             </a:extLst>
           </p:cNvPr>
@@ -10215,7 +10215,7 @@
     </p:spTree>
     <p:extLst>
       <p:ext uri="{BB962C8B-B14F-4D97-AF65-F5344CB8AC3E}">
-        <p14:creationId xmlns:p14="http://schemas.microsoft.com/office/powerpoint/2010/main" val="1913884957"/>
+        <p14:creationId xmlns:p14="http://schemas.microsoft.com/office/powerpoint/2010/main" val="1370468228"/>
       </p:ext>
     </p:extLst>
   </p:cSld>
@@ -10246,7 +10246,7 @@
           <p:cNvPr id="9" name="">
             <a:extLst xmlns:a="http://schemas.openxmlformats.org/drawingml/2006/main">
               <a:ext uri="{FF2B5EF4-FFF2-40B4-BE49-F238E27FC236}">
-                <a16:creationId xmlns:a16="http://schemas.microsoft.com/office/drawing/2014/main" id="{6E0DFEC4-41E1-4ECC-B63F-46C48A00AE41}"/>
+                <a16:creationId xmlns:a16="http://schemas.microsoft.com/office/drawing/2014/main" id="{DC34146E-8C79-4DB4-AA29-572788D54A2F}"/>
               </a:ext>
             </a:extLst>
           </p:cNvPr>
@@ -10404,7 +10404,7 @@
           <p:cNvPr id="2" name="">
             <a:extLst xmlns:a="http://schemas.openxmlformats.org/drawingml/2006/main">
               <a:ext uri="{FF2B5EF4-FFF2-40B4-BE49-F238E27FC236}">
-                <a16:creationId xmlns:a16="http://schemas.microsoft.com/office/drawing/2014/main" id="{2AF5BC12-B45C-45C7-B2A0-AEC990F3906B}"/>
+                <a16:creationId xmlns:a16="http://schemas.microsoft.com/office/drawing/2014/main" id="{92AE4806-FA1A-47B9-A50A-F856D8960997}"/>
               </a:ext>
             </a:extLst>
           </p:cNvPr>
@@ -10562,7 +10562,7 @@
           <p:cNvPr id="3" name="">
             <a:extLst xmlns:a="http://schemas.openxmlformats.org/drawingml/2006/main">
               <a:ext uri="{FF2B5EF4-FFF2-40B4-BE49-F238E27FC236}">
-                <a16:creationId xmlns:a16="http://schemas.microsoft.com/office/drawing/2014/main" id="{B948B205-431A-46F8-B9A6-56D88C706730}"/>
+                <a16:creationId xmlns:a16="http://schemas.microsoft.com/office/drawing/2014/main" id="{5D57B1B6-8377-4FB1-8D48-AC87C8EC9DAF}"/>
               </a:ext>
             </a:extLst>
           </p:cNvPr>
@@ -10720,7 +10720,7 @@
           <p:cNvPr id="4" name="">
             <a:extLst xmlns:a="http://schemas.openxmlformats.org/drawingml/2006/main">
               <a:ext uri="{FF2B5EF4-FFF2-40B4-BE49-F238E27FC236}">
-                <a16:creationId xmlns:a16="http://schemas.microsoft.com/office/drawing/2014/main" id="{2A9CD0DC-ACF3-4DA5-887F-0DC7E111B124}"/>
+                <a16:creationId xmlns:a16="http://schemas.microsoft.com/office/drawing/2014/main" id="{262A0007-58A5-4D8F-966F-603679204D65}"/>
               </a:ext>
             </a:extLst>
           </p:cNvPr>
@@ -10878,7 +10878,7 @@
           <p:cNvPr id="5" name="">
             <a:extLst xmlns:a="http://schemas.openxmlformats.org/drawingml/2006/main">
               <a:ext uri="{FF2B5EF4-FFF2-40B4-BE49-F238E27FC236}">
-                <a16:creationId xmlns:a16="http://schemas.microsoft.com/office/drawing/2014/main" id="{0D73F85B-31B3-4978-BCEE-2D727E17EF55}"/>
+                <a16:creationId xmlns:a16="http://schemas.microsoft.com/office/drawing/2014/main" id="{1EC1DADB-FE16-405E-A9AA-A3592475F67F}"/>
               </a:ext>
             </a:extLst>
           </p:cNvPr>
@@ -11036,7 +11036,7 @@
           <p:cNvPr id="6" name="">
             <a:extLst xmlns:a="http://schemas.openxmlformats.org/drawingml/2006/main">
               <a:ext uri="{FF2B5EF4-FFF2-40B4-BE49-F238E27FC236}">
-                <a16:creationId xmlns:a16="http://schemas.microsoft.com/office/drawing/2014/main" id="{D1314C99-7C46-41BA-A175-66B905958EC7}"/>
+                <a16:creationId xmlns:a16="http://schemas.microsoft.com/office/drawing/2014/main" id="{0D2B07F6-C72A-43D5-9C1D-4EFF51D11EBC}"/>
               </a:ext>
             </a:extLst>
           </p:cNvPr>
@@ -11240,7 +11240,7 @@
           <p:cNvPr id="7" name="">
             <a:extLst xmlns:a="http://schemas.openxmlformats.org/drawingml/2006/main">
               <a:ext uri="{FF2B5EF4-FFF2-40B4-BE49-F238E27FC236}">
-                <a16:creationId xmlns:a16="http://schemas.microsoft.com/office/drawing/2014/main" id="{5B3250D9-AC56-4DAF-B715-73121074FCE1}"/>
+                <a16:creationId xmlns:a16="http://schemas.microsoft.com/office/drawing/2014/main" id="{699E7CAD-5ED9-4FDA-8D14-62A0477309F9}"/>
               </a:ext>
             </a:extLst>
           </p:cNvPr>
@@ -11449,7 +11449,7 @@
           <p:cNvPr id="8" name="">
             <a:extLst xmlns:a="http://schemas.openxmlformats.org/drawingml/2006/main">
               <a:ext uri="{FF2B5EF4-FFF2-40B4-BE49-F238E27FC236}">
-                <a16:creationId xmlns:a16="http://schemas.microsoft.com/office/drawing/2014/main" id="{18A3AEA8-8A55-4EC6-8B77-D924FB47B08D}"/>
+                <a16:creationId xmlns:a16="http://schemas.microsoft.com/office/drawing/2014/main" id="{987AD0F8-3AB2-49BB-9CA7-6CBE27AF793B}"/>
               </a:ext>
             </a:extLst>
           </p:cNvPr>
@@ -11605,7 +11605,7 @@
     </p:spTree>
     <p:extLst>
       <p:ext uri="{BB962C8B-B14F-4D97-AF65-F5344CB8AC3E}">
-        <p14:creationId xmlns:p14="http://schemas.microsoft.com/office/powerpoint/2010/main" val="1684121831"/>
+        <p14:creationId xmlns:p14="http://schemas.microsoft.com/office/powerpoint/2010/main" val="198423650"/>
       </p:ext>
     </p:extLst>
   </p:cSld>
@@ -11636,7 +11636,7 @@
           <p:cNvPr id="7" name="">
             <a:extLst xmlns:a="http://schemas.openxmlformats.org/drawingml/2006/main">
               <a:ext uri="{FF2B5EF4-FFF2-40B4-BE49-F238E27FC236}">
-                <a16:creationId xmlns:a16="http://schemas.microsoft.com/office/drawing/2014/main" id="{DE212B00-4D15-4706-AA5E-EF8DADD599BA}"/>
+                <a16:creationId xmlns:a16="http://schemas.microsoft.com/office/drawing/2014/main" id="{ADC7A2AC-52B0-4F0E-8017-7C6E1B594846}"/>
               </a:ext>
             </a:extLst>
           </p:cNvPr>
@@ -11794,7 +11794,7 @@
           <p:cNvPr id="2" name="">
             <a:extLst xmlns:a="http://schemas.openxmlformats.org/drawingml/2006/main">
               <a:ext uri="{FF2B5EF4-FFF2-40B4-BE49-F238E27FC236}">
-                <a16:creationId xmlns:a16="http://schemas.microsoft.com/office/drawing/2014/main" id="{8EBEBEEB-17F1-42DF-B992-818B4047ECC6}"/>
+                <a16:creationId xmlns:a16="http://schemas.microsoft.com/office/drawing/2014/main" id="{CC4C1DE5-2664-4DD4-8FC6-EC606A0A833C}"/>
               </a:ext>
             </a:extLst>
           </p:cNvPr>
@@ -11952,7 +11952,7 @@
           <p:cNvPr id="3" name="">
             <a:extLst xmlns:a="http://schemas.openxmlformats.org/drawingml/2006/main">
               <a:ext uri="{FF2B5EF4-FFF2-40B4-BE49-F238E27FC236}">
-                <a16:creationId xmlns:a16="http://schemas.microsoft.com/office/drawing/2014/main" id="{2F8FB984-5E64-42D8-A9C6-FC03657613BA}"/>
+                <a16:creationId xmlns:a16="http://schemas.microsoft.com/office/drawing/2014/main" id="{CB77ECE7-76A1-42AD-BB60-247BF715BC01}"/>
               </a:ext>
             </a:extLst>
           </p:cNvPr>
@@ -12110,7 +12110,7 @@
           <p:cNvPr id="4" name="">
             <a:extLst xmlns:a="http://schemas.openxmlformats.org/drawingml/2006/main">
               <a:ext uri="{FF2B5EF4-FFF2-40B4-BE49-F238E27FC236}">
-                <a16:creationId xmlns:a16="http://schemas.microsoft.com/office/drawing/2014/main" id="{D41E303C-DF97-4B95-95EB-E3DB3AF920FB}"/>
+                <a16:creationId xmlns:a16="http://schemas.microsoft.com/office/drawing/2014/main" id="{230F5842-B4D5-4502-BCBB-036319EC6256}"/>
               </a:ext>
             </a:extLst>
           </p:cNvPr>
@@ -12314,7 +12314,7 @@
           <p:cNvPr id="5" name="">
             <a:extLst xmlns:a="http://schemas.openxmlformats.org/drawingml/2006/main">
               <a:ext uri="{FF2B5EF4-FFF2-40B4-BE49-F238E27FC236}">
-                <a16:creationId xmlns:a16="http://schemas.microsoft.com/office/drawing/2014/main" id="{A16E9036-9813-4680-B751-E323E3C8FE5F}"/>
+                <a16:creationId xmlns:a16="http://schemas.microsoft.com/office/drawing/2014/main" id="{B8A9A942-485F-4883-AA19-F97F3746B4AF}"/>
               </a:ext>
             </a:extLst>
           </p:cNvPr>
@@ -12754,7 +12754,7 @@
           <p:cNvPr id="6" name="">
             <a:extLst xmlns:a="http://schemas.openxmlformats.org/drawingml/2006/main">
               <a:ext uri="{FF2B5EF4-FFF2-40B4-BE49-F238E27FC236}">
-                <a16:creationId xmlns:a16="http://schemas.microsoft.com/office/drawing/2014/main" id="{AE9E773C-8FBA-4581-ACCA-4E1F5261223C}"/>
+                <a16:creationId xmlns:a16="http://schemas.microsoft.com/office/drawing/2014/main" id="{06593295-F4AA-4556-A5DD-848EE59EF95B}"/>
               </a:ext>
             </a:extLst>
           </p:cNvPr>
@@ -12910,7 +12910,7 @@
     </p:spTree>
     <p:extLst>
       <p:ext uri="{BB962C8B-B14F-4D97-AF65-F5344CB8AC3E}">
-        <p14:creationId xmlns:p14="http://schemas.microsoft.com/office/powerpoint/2010/main" val="1031220251"/>
+        <p14:creationId xmlns:p14="http://schemas.microsoft.com/office/powerpoint/2010/main" val="207498084"/>
       </p:ext>
     </p:extLst>
   </p:cSld>
@@ -12941,7 +12941,7 @@
           <p:cNvPr id="7" name="">
             <a:extLst xmlns:a="http://schemas.openxmlformats.org/drawingml/2006/main">
               <a:ext uri="{FF2B5EF4-FFF2-40B4-BE49-F238E27FC236}">
-                <a16:creationId xmlns:a16="http://schemas.microsoft.com/office/drawing/2014/main" id="{D3C1DD63-5AAA-4B6C-B72A-32CB09683C00}"/>
+                <a16:creationId xmlns:a16="http://schemas.microsoft.com/office/drawing/2014/main" id="{D9251A22-96D8-4538-A76E-64902370CF94}"/>
               </a:ext>
             </a:extLst>
           </p:cNvPr>
@@ -13099,7 +13099,7 @@
           <p:cNvPr id="2" name="">
             <a:extLst xmlns:a="http://schemas.openxmlformats.org/drawingml/2006/main">
               <a:ext uri="{FF2B5EF4-FFF2-40B4-BE49-F238E27FC236}">
-                <a16:creationId xmlns:a16="http://schemas.microsoft.com/office/drawing/2014/main" id="{B08E2701-5247-401D-8A47-56B859E0C01B}"/>
+                <a16:creationId xmlns:a16="http://schemas.microsoft.com/office/drawing/2014/main" id="{43327F56-8DE8-4E61-83A1-B093D9885195}"/>
               </a:ext>
             </a:extLst>
           </p:cNvPr>
@@ -13257,7 +13257,7 @@
           <p:cNvPr id="3" name="">
             <a:extLst xmlns:a="http://schemas.openxmlformats.org/drawingml/2006/main">
               <a:ext uri="{FF2B5EF4-FFF2-40B4-BE49-F238E27FC236}">
-                <a16:creationId xmlns:a16="http://schemas.microsoft.com/office/drawing/2014/main" id="{0DC744C8-5A1E-49A8-A9B9-1A9F589A0B53}"/>
+                <a16:creationId xmlns:a16="http://schemas.microsoft.com/office/drawing/2014/main" id="{F88ECFF2-5515-4E8B-921B-2D7B637659A2}"/>
               </a:ext>
             </a:extLst>
           </p:cNvPr>
@@ -13415,7 +13415,7 @@
           <p:cNvPr id="4" name="">
             <a:extLst xmlns:a="http://schemas.openxmlformats.org/drawingml/2006/main">
               <a:ext uri="{FF2B5EF4-FFF2-40B4-BE49-F238E27FC236}">
-                <a16:creationId xmlns:a16="http://schemas.microsoft.com/office/drawing/2014/main" id="{4E5440E2-E150-460B-A2DF-103B499974B9}"/>
+                <a16:creationId xmlns:a16="http://schemas.microsoft.com/office/drawing/2014/main" id="{AFC73ACD-BB20-4B0A-8FB6-2A1990BD8226}"/>
               </a:ext>
             </a:extLst>
           </p:cNvPr>
@@ -13573,7 +13573,7 @@
           <p:cNvPr id="5" name="">
             <a:extLst xmlns:a="http://schemas.openxmlformats.org/drawingml/2006/main">
               <a:ext uri="{FF2B5EF4-FFF2-40B4-BE49-F238E27FC236}">
-                <a16:creationId xmlns:a16="http://schemas.microsoft.com/office/drawing/2014/main" id="{F428C760-66E3-4B2F-ADF4-D73CBABB29D5}"/>
+                <a16:creationId xmlns:a16="http://schemas.microsoft.com/office/drawing/2014/main" id="{7B1A634E-267D-44EE-96B3-6EEE677E79D3}"/>
               </a:ext>
             </a:extLst>
           </p:cNvPr>
@@ -14084,7 +14084,7 @@
           <p:cNvPr id="6" name="">
             <a:extLst xmlns:a="http://schemas.openxmlformats.org/drawingml/2006/main">
               <a:ext uri="{FF2B5EF4-FFF2-40B4-BE49-F238E27FC236}">
-                <a16:creationId xmlns:a16="http://schemas.microsoft.com/office/drawing/2014/main" id="{8F73B523-0625-4806-88FE-74F628D26C79}"/>
+                <a16:creationId xmlns:a16="http://schemas.microsoft.com/office/drawing/2014/main" id="{73E0D50F-FE0B-4DD9-80B3-455CCFAAAB83}"/>
               </a:ext>
             </a:extLst>
           </p:cNvPr>
@@ -14263,7 +14263,7 @@
     </p:spTree>
     <p:extLst>
       <p:ext uri="{BB962C8B-B14F-4D97-AF65-F5344CB8AC3E}">
-        <p14:creationId xmlns:p14="http://schemas.microsoft.com/office/powerpoint/2010/main" val="1999128155"/>
+        <p14:creationId xmlns:p14="http://schemas.microsoft.com/office/powerpoint/2010/main" val="1138922376"/>
       </p:ext>
     </p:extLst>
   </p:cSld>
@@ -14294,7 +14294,7 @@
           <p:cNvPr id="9" name="">
             <a:extLst xmlns:a="http://schemas.openxmlformats.org/drawingml/2006/main">
               <a:ext uri="{FF2B5EF4-FFF2-40B4-BE49-F238E27FC236}">
-                <a16:creationId xmlns:a16="http://schemas.microsoft.com/office/drawing/2014/main" id="{C3905871-CDAF-42C8-9B20-672D1FC87B5B}"/>
+                <a16:creationId xmlns:a16="http://schemas.microsoft.com/office/drawing/2014/main" id="{0B098F45-5798-483C-B29F-2237DDA1E771}"/>
               </a:ext>
             </a:extLst>
           </p:cNvPr>
@@ -14452,7 +14452,7 @@
           <p:cNvPr id="2" name="">
             <a:extLst xmlns:a="http://schemas.openxmlformats.org/drawingml/2006/main">
               <a:ext uri="{FF2B5EF4-FFF2-40B4-BE49-F238E27FC236}">
-                <a16:creationId xmlns:a16="http://schemas.microsoft.com/office/drawing/2014/main" id="{0FF21A24-6428-497D-A545-BAF5AB8D61AF}"/>
+                <a16:creationId xmlns:a16="http://schemas.microsoft.com/office/drawing/2014/main" id="{D5F41F56-A569-4249-840A-382FBA8D68CA}"/>
               </a:ext>
             </a:extLst>
           </p:cNvPr>
@@ -14610,7 +14610,7 @@
           <p:cNvPr id="3" name="">
             <a:extLst xmlns:a="http://schemas.openxmlformats.org/drawingml/2006/main">
               <a:ext uri="{FF2B5EF4-FFF2-40B4-BE49-F238E27FC236}">
-                <a16:creationId xmlns:a16="http://schemas.microsoft.com/office/drawing/2014/main" id="{582397C9-88B7-4EA3-AEFC-FE60C28742E0}"/>
+                <a16:creationId xmlns:a16="http://schemas.microsoft.com/office/drawing/2014/main" id="{04CBF311-EE04-46AC-9D9A-1FC617C70B92}"/>
               </a:ext>
             </a:extLst>
           </p:cNvPr>
@@ -14768,7 +14768,7 @@
           <p:cNvPr id="4" name="">
             <a:extLst xmlns:a="http://schemas.openxmlformats.org/drawingml/2006/main">
               <a:ext uri="{FF2B5EF4-FFF2-40B4-BE49-F238E27FC236}">
-                <a16:creationId xmlns:a16="http://schemas.microsoft.com/office/drawing/2014/main" id="{169CAC20-A108-4B10-A552-571AD0DBD661}"/>
+                <a16:creationId xmlns:a16="http://schemas.microsoft.com/office/drawing/2014/main" id="{0E87A78E-6FB0-4E0C-9317-6BE89D8EEDFB}"/>
               </a:ext>
             </a:extLst>
           </p:cNvPr>
@@ -14926,7 +14926,7 @@
           <p:cNvPr id="5" name="">
             <a:extLst xmlns:a="http://schemas.openxmlformats.org/drawingml/2006/main">
               <a:ext uri="{FF2B5EF4-FFF2-40B4-BE49-F238E27FC236}">
-                <a16:creationId xmlns:a16="http://schemas.microsoft.com/office/drawing/2014/main" id="{0F2390E1-F8E5-4BE2-9CEE-B70DFF303739}"/>
+                <a16:creationId xmlns:a16="http://schemas.microsoft.com/office/drawing/2014/main" id="{45A25D04-5951-45E5-9F65-FF00B5764FE7}"/>
               </a:ext>
             </a:extLst>
           </p:cNvPr>
@@ -15084,7 +15084,7 @@
           <p:cNvPr id="6" name="">
             <a:extLst xmlns:a="http://schemas.openxmlformats.org/drawingml/2006/main">
               <a:ext uri="{FF2B5EF4-FFF2-40B4-BE49-F238E27FC236}">
-                <a16:creationId xmlns:a16="http://schemas.microsoft.com/office/drawing/2014/main" id="{07193FEC-3A04-420A-8167-E741D06FE771}"/>
+                <a16:creationId xmlns:a16="http://schemas.microsoft.com/office/drawing/2014/main" id="{D3AE5345-08F8-47A9-9AE4-0B1CF9DCCF77}"/>
               </a:ext>
             </a:extLst>
           </p:cNvPr>
@@ -15242,7 +15242,7 @@
           <p:cNvPr id="7" name="">
             <a:extLst xmlns:a="http://schemas.openxmlformats.org/drawingml/2006/main">
               <a:ext uri="{FF2B5EF4-FFF2-40B4-BE49-F238E27FC236}">
-                <a16:creationId xmlns:a16="http://schemas.microsoft.com/office/drawing/2014/main" id="{0BB173C4-AD5B-4E78-B35F-D935BB2D42A4}"/>
+                <a16:creationId xmlns:a16="http://schemas.microsoft.com/office/drawing/2014/main" id="{8CC70F07-64CE-49DD-B47D-9B07F06FB4C1}"/>
               </a:ext>
             </a:extLst>
           </p:cNvPr>
@@ -15446,7 +15446,7 @@
           <p:cNvPr id="8" name="">
             <a:extLst xmlns:a="http://schemas.openxmlformats.org/drawingml/2006/main">
               <a:ext uri="{FF2B5EF4-FFF2-40B4-BE49-F238E27FC236}">
-                <a16:creationId xmlns:a16="http://schemas.microsoft.com/office/drawing/2014/main" id="{74F9C5AC-1F4C-4E81-BE8D-51FB167BC821}"/>
+                <a16:creationId xmlns:a16="http://schemas.microsoft.com/office/drawing/2014/main" id="{DBF968B4-D6BE-4D3B-921F-2357CA2B0BE8}"/>
               </a:ext>
             </a:extLst>
           </p:cNvPr>
@@ -15602,7 +15602,7 @@
     </p:spTree>
     <p:extLst>
       <p:ext uri="{BB962C8B-B14F-4D97-AF65-F5344CB8AC3E}">
-        <p14:creationId xmlns:p14="http://schemas.microsoft.com/office/powerpoint/2010/main" val="892223230"/>
+        <p14:creationId xmlns:p14="http://schemas.microsoft.com/office/powerpoint/2010/main" val="524051616"/>
       </p:ext>
     </p:extLst>
   </p:cSld>
@@ -15633,7 +15633,7 @@
           <p:cNvPr id="8" name="">
             <a:extLst xmlns:a="http://schemas.openxmlformats.org/drawingml/2006/main">
               <a:ext uri="{FF2B5EF4-FFF2-40B4-BE49-F238E27FC236}">
-                <a16:creationId xmlns:a16="http://schemas.microsoft.com/office/drawing/2014/main" id="{46D4EB58-4F13-453F-B432-A5AF25FEBE32}"/>
+                <a16:creationId xmlns:a16="http://schemas.microsoft.com/office/drawing/2014/main" id="{167EF4A5-3D9D-4A2D-B1FC-961B372D79E4}"/>
               </a:ext>
             </a:extLst>
           </p:cNvPr>
@@ -15791,7 +15791,7 @@
           <p:cNvPr id="2" name="">
             <a:extLst xmlns:a="http://schemas.openxmlformats.org/drawingml/2006/main">
               <a:ext uri="{FF2B5EF4-FFF2-40B4-BE49-F238E27FC236}">
-                <a16:creationId xmlns:a16="http://schemas.microsoft.com/office/drawing/2014/main" id="{8993BCE7-84A7-49C8-8ED5-1A527B60D514}"/>
+                <a16:creationId xmlns:a16="http://schemas.microsoft.com/office/drawing/2014/main" id="{1DB876F3-F989-489C-87FC-9352A88B2FE9}"/>
               </a:ext>
             </a:extLst>
           </p:cNvPr>
@@ -15949,7 +15949,7 @@
           <p:cNvPr id="3" name="">
             <a:extLst xmlns:a="http://schemas.openxmlformats.org/drawingml/2006/main">
               <a:ext uri="{FF2B5EF4-FFF2-40B4-BE49-F238E27FC236}">
-                <a16:creationId xmlns:a16="http://schemas.microsoft.com/office/drawing/2014/main" id="{9F7C038A-DF88-4CBA-AD77-95EBFB394124}"/>
+                <a16:creationId xmlns:a16="http://schemas.microsoft.com/office/drawing/2014/main" id="{651B8EC5-EF6C-415F-9CD5-14BA756A2764}"/>
               </a:ext>
             </a:extLst>
           </p:cNvPr>
@@ -16107,7 +16107,7 @@
           <p:cNvPr id="4" name="">
             <a:extLst xmlns:a="http://schemas.openxmlformats.org/drawingml/2006/main">
               <a:ext uri="{FF2B5EF4-FFF2-40B4-BE49-F238E27FC236}">
-                <a16:creationId xmlns:a16="http://schemas.microsoft.com/office/drawing/2014/main" id="{EA0C01BF-8C07-4B7E-8DA4-06C8EDC9A7BF}"/>
+                <a16:creationId xmlns:a16="http://schemas.microsoft.com/office/drawing/2014/main" id="{54825CA4-80B0-477D-9F41-DB3C91CADC25}"/>
               </a:ext>
             </a:extLst>
           </p:cNvPr>
@@ -16265,7 +16265,7 @@
           <p:cNvPr id="5" name="">
             <a:extLst xmlns:a="http://schemas.openxmlformats.org/drawingml/2006/main">
               <a:ext uri="{FF2B5EF4-FFF2-40B4-BE49-F238E27FC236}">
-                <a16:creationId xmlns:a16="http://schemas.microsoft.com/office/drawing/2014/main" id="{60591B57-30B7-4257-9F1F-F5844E0274F0}"/>
+                <a16:creationId xmlns:a16="http://schemas.microsoft.com/office/drawing/2014/main" id="{BEB6D38F-CBEE-4118-972E-EF63E94E27DA}"/>
               </a:ext>
             </a:extLst>
           </p:cNvPr>
@@ -16660,7 +16660,7 @@
           <p:cNvPr id="6" name="">
             <a:extLst xmlns:a="http://schemas.openxmlformats.org/drawingml/2006/main">
               <a:ext uri="{FF2B5EF4-FFF2-40B4-BE49-F238E27FC236}">
-                <a16:creationId xmlns:a16="http://schemas.microsoft.com/office/drawing/2014/main" id="{8D41C2D4-D019-4F01-9C8E-9A3484397F33}"/>
+                <a16:creationId xmlns:a16="http://schemas.microsoft.com/office/drawing/2014/main" id="{246A7C2D-8C04-49E7-8D23-D72E8AF3C410}"/>
               </a:ext>
             </a:extLst>
           </p:cNvPr>
@@ -16841,7 +16841,7 @@
           <p:cNvPr id="7" name="">
             <a:extLst xmlns:a="http://schemas.openxmlformats.org/drawingml/2006/main">
               <a:ext uri="{FF2B5EF4-FFF2-40B4-BE49-F238E27FC236}">
-                <a16:creationId xmlns:a16="http://schemas.microsoft.com/office/drawing/2014/main" id="{B3D1E100-050F-4AB2-810D-A6E2BF4821A5}"/>
+                <a16:creationId xmlns:a16="http://schemas.microsoft.com/office/drawing/2014/main" id="{D0893997-2B27-4B71-AC34-03EB295E9676}"/>
               </a:ext>
             </a:extLst>
           </p:cNvPr>
@@ -16997,7 +16997,7 @@
     </p:spTree>
     <p:extLst>
       <p:ext uri="{BB962C8B-B14F-4D97-AF65-F5344CB8AC3E}">
-        <p14:creationId xmlns:p14="http://schemas.microsoft.com/office/powerpoint/2010/main" val="887491309"/>
+        <p14:creationId xmlns:p14="http://schemas.microsoft.com/office/powerpoint/2010/main" val="2102186306"/>
       </p:ext>
     </p:extLst>
   </p:cSld>
@@ -17028,7 +17028,7 @@
           <p:cNvPr id="8" name="">
             <a:extLst xmlns:a="http://schemas.openxmlformats.org/drawingml/2006/main">
               <a:ext uri="{FF2B5EF4-FFF2-40B4-BE49-F238E27FC236}">
-                <a16:creationId xmlns:a16="http://schemas.microsoft.com/office/drawing/2014/main" id="{61602B12-7FF3-45B2-9C5B-466373F7157B}"/>
+                <a16:creationId xmlns:a16="http://schemas.microsoft.com/office/drawing/2014/main" id="{AEFAD1EB-9B11-459F-A44A-60EFF42A3179}"/>
               </a:ext>
             </a:extLst>
           </p:cNvPr>
@@ -17186,7 +17186,7 @@
           <p:cNvPr id="2" name="">
             <a:extLst xmlns:a="http://schemas.openxmlformats.org/drawingml/2006/main">
               <a:ext uri="{FF2B5EF4-FFF2-40B4-BE49-F238E27FC236}">
-                <a16:creationId xmlns:a16="http://schemas.microsoft.com/office/drawing/2014/main" id="{69C11F80-C295-43A0-A298-07D82842A5A6}"/>
+                <a16:creationId xmlns:a16="http://schemas.microsoft.com/office/drawing/2014/main" id="{32A52858-6483-440A-8D72-D37EA8F22842}"/>
               </a:ext>
             </a:extLst>
           </p:cNvPr>
@@ -17344,7 +17344,7 @@
           <p:cNvPr id="3" name="">
             <a:extLst xmlns:a="http://schemas.openxmlformats.org/drawingml/2006/main">
               <a:ext uri="{FF2B5EF4-FFF2-40B4-BE49-F238E27FC236}">
-                <a16:creationId xmlns:a16="http://schemas.microsoft.com/office/drawing/2014/main" id="{2983C6E3-16E3-4458-B10B-7469401B8B2D}"/>
+                <a16:creationId xmlns:a16="http://schemas.microsoft.com/office/drawing/2014/main" id="{4043B421-51A7-4CD3-A9D2-05DD1474FBD9}"/>
               </a:ext>
             </a:extLst>
           </p:cNvPr>
@@ -17502,7 +17502,7 @@
           <p:cNvPr id="4" name="">
             <a:extLst xmlns:a="http://schemas.openxmlformats.org/drawingml/2006/main">
               <a:ext uri="{FF2B5EF4-FFF2-40B4-BE49-F238E27FC236}">
-                <a16:creationId xmlns:a16="http://schemas.microsoft.com/office/drawing/2014/main" id="{768589E0-76A9-429D-B2D8-AF2E56BEAB4F}"/>
+                <a16:creationId xmlns:a16="http://schemas.microsoft.com/office/drawing/2014/main" id="{D2B72815-2CF1-402B-B144-D2E21F5B1DAF}"/>
               </a:ext>
             </a:extLst>
           </p:cNvPr>
@@ -17650,7 +17650,7 @@
                 <a:ea typeface="Arial"/>
                 <a:cs typeface="Arial"/>
               </a:rPr>
-              <a:t>em_ruido.py</a:t>
+              <a:t>em.cpp (C++17)</a:t>
             </a:r>
           </a:p>
         </p:txBody>
@@ -17660,7 +17660,7 @@
           <p:cNvPr id="5" name="">
             <a:extLst xmlns:a="http://schemas.openxmlformats.org/drawingml/2006/main">
               <a:ext uri="{FF2B5EF4-FFF2-40B4-BE49-F238E27FC236}">
-                <a16:creationId xmlns:a16="http://schemas.microsoft.com/office/drawing/2014/main" id="{28EE2540-6697-4B61-B966-DFA1FE104BA2}"/>
+                <a16:creationId xmlns:a16="http://schemas.microsoft.com/office/drawing/2014/main" id="{B4887D3F-B7FB-4EDB-B82E-AEECF4C10176}"/>
               </a:ext>
             </a:extLst>
           </p:cNvPr>
@@ -17933,7 +17933,7 @@
           <p:cNvPr id="6" name="">
             <a:extLst xmlns:a="http://schemas.openxmlformats.org/drawingml/2006/main">
               <a:ext uri="{FF2B5EF4-FFF2-40B4-BE49-F238E27FC236}">
-                <a16:creationId xmlns:a16="http://schemas.microsoft.com/office/drawing/2014/main" id="{E80091A0-7BD7-4E6D-8AA6-2E57E51510CD}"/>
+                <a16:creationId xmlns:a16="http://schemas.microsoft.com/office/drawing/2014/main" id="{FF445BFC-24F6-4CF0-A4AA-00A8AB2E7DDE}"/>
               </a:ext>
             </a:extLst>
           </p:cNvPr>
@@ -18114,7 +18114,7 @@
           <p:cNvPr id="7" name="">
             <a:extLst xmlns:a="http://schemas.openxmlformats.org/drawingml/2006/main">
               <a:ext uri="{FF2B5EF4-FFF2-40B4-BE49-F238E27FC236}">
-                <a16:creationId xmlns:a16="http://schemas.microsoft.com/office/drawing/2014/main" id="{E9DEB1E7-38E7-42B5-B9B2-B0EB67E7092C}"/>
+                <a16:creationId xmlns:a16="http://schemas.microsoft.com/office/drawing/2014/main" id="{0AC480D7-1D0F-4292-98A8-CE501D34A296}"/>
               </a:ext>
             </a:extLst>
           </p:cNvPr>
@@ -18270,7 +18270,7 @@
     </p:spTree>
     <p:extLst>
       <p:ext uri="{BB962C8B-B14F-4D97-AF65-F5344CB8AC3E}">
-        <p14:creationId xmlns:p14="http://schemas.microsoft.com/office/powerpoint/2010/main" val="1960389097"/>
+        <p14:creationId xmlns:p14="http://schemas.microsoft.com/office/powerpoint/2010/main" val="1917893663"/>
       </p:ext>
     </p:extLst>
   </p:cSld>
@@ -18301,7 +18301,7 @@
           <p:cNvPr id="7" name="">
             <a:extLst xmlns:a="http://schemas.openxmlformats.org/drawingml/2006/main">
               <a:ext uri="{FF2B5EF4-FFF2-40B4-BE49-F238E27FC236}">
-                <a16:creationId xmlns:a16="http://schemas.microsoft.com/office/drawing/2014/main" id="{52A7461F-B58C-43FB-82F1-A7D8581A6C90}"/>
+                <a16:creationId xmlns:a16="http://schemas.microsoft.com/office/drawing/2014/main" id="{D01A2CE5-455D-4A85-9193-C844EE6AABB3}"/>
               </a:ext>
             </a:extLst>
           </p:cNvPr>
@@ -18459,7 +18459,7 @@
           <p:cNvPr id="2" name="">
             <a:extLst xmlns:a="http://schemas.openxmlformats.org/drawingml/2006/main">
               <a:ext uri="{FF2B5EF4-FFF2-40B4-BE49-F238E27FC236}">
-                <a16:creationId xmlns:a16="http://schemas.microsoft.com/office/drawing/2014/main" id="{07DE761A-8C91-4456-8399-1E7756922861}"/>
+                <a16:creationId xmlns:a16="http://schemas.microsoft.com/office/drawing/2014/main" id="{970544B3-A1BD-4E12-A368-E27A00FA538F}"/>
               </a:ext>
             </a:extLst>
           </p:cNvPr>
@@ -18617,7 +18617,7 @@
           <p:cNvPr id="3" name="">
             <a:extLst xmlns:a="http://schemas.openxmlformats.org/drawingml/2006/main">
               <a:ext uri="{FF2B5EF4-FFF2-40B4-BE49-F238E27FC236}">
-                <a16:creationId xmlns:a16="http://schemas.microsoft.com/office/drawing/2014/main" id="{9B6C1C72-5F44-4944-95E0-5DCB7174E36A}"/>
+                <a16:creationId xmlns:a16="http://schemas.microsoft.com/office/drawing/2014/main" id="{F4FB0B95-E825-46AB-8565-67D762742313}"/>
               </a:ext>
             </a:extLst>
           </p:cNvPr>
@@ -18775,7 +18775,7 @@
           <p:cNvPr id="4" name="">
             <a:extLst xmlns:a="http://schemas.openxmlformats.org/drawingml/2006/main">
               <a:ext uri="{FF2B5EF4-FFF2-40B4-BE49-F238E27FC236}">
-                <a16:creationId xmlns:a16="http://schemas.microsoft.com/office/drawing/2014/main" id="{214D72E1-4CC1-4945-BE79-0DFEDB0120A1}"/>
+                <a16:creationId xmlns:a16="http://schemas.microsoft.com/office/drawing/2014/main" id="{3F9D44EE-7547-4C96-BE67-B8EF479348CF}"/>
               </a:ext>
             </a:extLst>
           </p:cNvPr>
@@ -19964,7 +19964,7 @@
           <p:cNvPr id="5" name="">
             <a:extLst xmlns:a="http://schemas.openxmlformats.org/drawingml/2006/main">
               <a:ext uri="{FF2B5EF4-FFF2-40B4-BE49-F238E27FC236}">
-                <a16:creationId xmlns:a16="http://schemas.microsoft.com/office/drawing/2014/main" id="{7F667C4A-7621-4B3A-A887-CE2D075EDFF1}"/>
+                <a16:creationId xmlns:a16="http://schemas.microsoft.com/office/drawing/2014/main" id="{998B38B3-A9FB-43E6-A29F-DB45A8645AD6}"/>
               </a:ext>
             </a:extLst>
           </p:cNvPr>
@@ -20145,7 +20145,7 @@
           <p:cNvPr id="6" name="">
             <a:extLst xmlns:a="http://schemas.openxmlformats.org/drawingml/2006/main">
               <a:ext uri="{FF2B5EF4-FFF2-40B4-BE49-F238E27FC236}">
-                <a16:creationId xmlns:a16="http://schemas.microsoft.com/office/drawing/2014/main" id="{37C216CB-B981-4C61-8A29-1B625CC65CE5}"/>
+                <a16:creationId xmlns:a16="http://schemas.microsoft.com/office/drawing/2014/main" id="{851DF178-9186-4808-8D33-BD0F047379B1}"/>
               </a:ext>
             </a:extLst>
           </p:cNvPr>
@@ -20301,7 +20301,7 @@
     </p:spTree>
     <p:extLst>
       <p:ext uri="{BB962C8B-B14F-4D97-AF65-F5344CB8AC3E}">
-        <p14:creationId xmlns:p14="http://schemas.microsoft.com/office/powerpoint/2010/main" val="1578150203"/>
+        <p14:creationId xmlns:p14="http://schemas.microsoft.com/office/powerpoint/2010/main" val="2127196642"/>
       </p:ext>
     </p:extLst>
   </p:cSld>
@@ -20332,7 +20332,7 @@
           <p:cNvPr id="8" name="">
             <a:extLst xmlns:a="http://schemas.openxmlformats.org/drawingml/2006/main">
               <a:ext uri="{FF2B5EF4-FFF2-40B4-BE49-F238E27FC236}">
-                <a16:creationId xmlns:a16="http://schemas.microsoft.com/office/drawing/2014/main" id="{B3892C8C-F472-4FC8-A8C5-E0943B212477}"/>
+                <a16:creationId xmlns:a16="http://schemas.microsoft.com/office/drawing/2014/main" id="{88812777-4834-423A-9F4A-ADB612F43B0C}"/>
               </a:ext>
             </a:extLst>
           </p:cNvPr>
@@ -20490,7 +20490,7 @@
           <p:cNvPr id="2" name="">
             <a:extLst xmlns:a="http://schemas.openxmlformats.org/drawingml/2006/main">
               <a:ext uri="{FF2B5EF4-FFF2-40B4-BE49-F238E27FC236}">
-                <a16:creationId xmlns:a16="http://schemas.microsoft.com/office/drawing/2014/main" id="{B743D112-2D2B-4569-B8E3-140D9EA5600E}"/>
+                <a16:creationId xmlns:a16="http://schemas.microsoft.com/office/drawing/2014/main" id="{8B961E25-FDA2-40B1-852E-576F9EBA4730}"/>
               </a:ext>
             </a:extLst>
           </p:cNvPr>
@@ -20648,7 +20648,7 @@
           <p:cNvPr id="3" name="">
             <a:extLst xmlns:a="http://schemas.openxmlformats.org/drawingml/2006/main">
               <a:ext uri="{FF2B5EF4-FFF2-40B4-BE49-F238E27FC236}">
-                <a16:creationId xmlns:a16="http://schemas.microsoft.com/office/drawing/2014/main" id="{6939B744-3FB2-453A-914D-57C7BFD6063F}"/>
+                <a16:creationId xmlns:a16="http://schemas.microsoft.com/office/drawing/2014/main" id="{035FCBBE-722C-4738-9148-FBD2EFBE4E7F}"/>
               </a:ext>
             </a:extLst>
           </p:cNvPr>
@@ -20806,7 +20806,7 @@
           <p:cNvPr id="4" name="">
             <a:extLst xmlns:a="http://schemas.openxmlformats.org/drawingml/2006/main">
               <a:ext uri="{FF2B5EF4-FFF2-40B4-BE49-F238E27FC236}">
-                <a16:creationId xmlns:a16="http://schemas.microsoft.com/office/drawing/2014/main" id="{A9F35E3F-1212-44B8-AC4A-9DD679404079}"/>
+                <a16:creationId xmlns:a16="http://schemas.microsoft.com/office/drawing/2014/main" id="{A44FB4A0-5020-4F31-89CE-D9D210B4EA3E}"/>
               </a:ext>
             </a:extLst>
           </p:cNvPr>
@@ -20987,7 +20987,7 @@
           <p:cNvPr id="5" name="">
             <a:extLst xmlns:a="http://schemas.openxmlformats.org/drawingml/2006/main">
               <a:ext uri="{FF2B5EF4-FFF2-40B4-BE49-F238E27FC236}">
-                <a16:creationId xmlns:a16="http://schemas.microsoft.com/office/drawing/2014/main" id="{E003B96B-9050-4662-81D1-0ECAD20545BB}"/>
+                <a16:creationId xmlns:a16="http://schemas.microsoft.com/office/drawing/2014/main" id="{E66EFC70-2AF6-4D4B-9F7D-26263DABF8C5}"/>
               </a:ext>
             </a:extLst>
           </p:cNvPr>
@@ -21168,7 +21168,7 @@
           <p:cNvPr id="6" name="">
             <a:extLst xmlns:a="http://schemas.openxmlformats.org/drawingml/2006/main">
               <a:ext uri="{FF2B5EF4-FFF2-40B4-BE49-F238E27FC236}">
-                <a16:creationId xmlns:a16="http://schemas.microsoft.com/office/drawing/2014/main" id="{34DAC9EC-DEC4-42C7-9882-F0561FBD1F6F}"/>
+                <a16:creationId xmlns:a16="http://schemas.microsoft.com/office/drawing/2014/main" id="{F5D4582D-7A83-44A9-A67E-9F8C7B41051A}"/>
               </a:ext>
             </a:extLst>
           </p:cNvPr>
@@ -21349,7 +21349,7 @@
           <p:cNvPr id="7" name="">
             <a:extLst xmlns:a="http://schemas.openxmlformats.org/drawingml/2006/main">
               <a:ext uri="{FF2B5EF4-FFF2-40B4-BE49-F238E27FC236}">
-                <a16:creationId xmlns:a16="http://schemas.microsoft.com/office/drawing/2014/main" id="{7A90673A-74C4-490D-820F-1E8967385011}"/>
+                <a16:creationId xmlns:a16="http://schemas.microsoft.com/office/drawing/2014/main" id="{61BC324D-047F-4F7F-81D8-5132550780F0}"/>
               </a:ext>
             </a:extLst>
           </p:cNvPr>
@@ -21505,7 +21505,7 @@
     </p:spTree>
     <p:extLst>
       <p:ext uri="{BB962C8B-B14F-4D97-AF65-F5344CB8AC3E}">
-        <p14:creationId xmlns:p14="http://schemas.microsoft.com/office/powerpoint/2010/main" val="1500757734"/>
+        <p14:creationId xmlns:p14="http://schemas.microsoft.com/office/powerpoint/2010/main" val="114360852"/>
       </p:ext>
     </p:extLst>
   </p:cSld>

</xml_diff>